<commit_message>
Add visual step-by-step table flow diagram and table-to-table transition pipeline slides
</commit_message>
<xml_diff>
--- a/LMS_Data_Architecture_and_Flow.pptx
+++ b/LMS_Data_Architecture_and_Flow.pptx
@@ -3221,7 +3221,7 @@
               </a:defRPr>
             </a:pPr>
             <a:r>
-              <a:t>LMS DATA ARCHITECTURE &amp; SYSTEM FLOW</a:t>
+              <a:t>LMS SYSTEM DATA FLOW &amp; ARCHITECTURE</a:t>
             </a:r>
           </a:p>
           <a:p>
@@ -3237,7 +3237,7 @@
               </a:defRPr>
             </a:pPr>
             <a:r>
-              <a:t>End-to-End Business Pipeline, ER Table Connections &amp; 22-Table Schema for Data Analytics</a:t>
+              <a:t>End-to-End Table Data Flow, ER Connections &amp; 22-Table Relational Model for Students</a:t>
             </a:r>
           </a:p>
           <a:p>
@@ -3441,7 +3441,7 @@
               <a:spcAft>
                 <a:spcPts val="800"/>
               </a:spcAft>
-              <a:defRPr sz="1700" b="1">
+              <a:defRPr sz="1600" b="1">
                 <a:solidFill>
                   <a:srgbClr val="0066FF"/>
                 </a:solidFill>
@@ -3457,7 +3457,7 @@
               <a:spcAft>
                 <a:spcPts val="400"/>
               </a:spcAft>
-              <a:defRPr sz="1200">
+              <a:defRPr sz="1150">
                 <a:solidFill>
                   <a:srgbClr val="1E293B"/>
                 </a:solidFill>
@@ -3473,7 +3473,7 @@
               <a:spcAft>
                 <a:spcPts val="400"/>
               </a:spcAft>
-              <a:defRPr sz="1200">
+              <a:defRPr sz="1150">
                 <a:solidFill>
                   <a:srgbClr val="1E293B"/>
                 </a:solidFill>
@@ -3489,7 +3489,7 @@
               <a:spcAft>
                 <a:spcPts val="400"/>
               </a:spcAft>
-              <a:defRPr sz="1200">
+              <a:defRPr sz="1150">
                 <a:solidFill>
                   <a:srgbClr val="1E293B"/>
                 </a:solidFill>
@@ -3505,7 +3505,7 @@
               <a:spcAft>
                 <a:spcPts val="400"/>
               </a:spcAft>
-              <a:defRPr sz="1200">
+              <a:defRPr sz="1150">
                 <a:solidFill>
                   <a:srgbClr val="1E293B"/>
                 </a:solidFill>
@@ -3589,7 +3589,7 @@
               <a:spcAft>
                 <a:spcPts val="800"/>
               </a:spcAft>
-              <a:defRPr sz="1700" b="1">
+              <a:defRPr sz="1600" b="1">
                 <a:solidFill>
                   <a:srgbClr val="10B981"/>
                 </a:solidFill>
@@ -3605,7 +3605,7 @@
               <a:spcAft>
                 <a:spcPts val="400"/>
               </a:spcAft>
-              <a:defRPr sz="1200">
+              <a:defRPr sz="1150">
                 <a:solidFill>
                   <a:srgbClr val="1E293B"/>
                 </a:solidFill>
@@ -3621,7 +3621,7 @@
               <a:spcAft>
                 <a:spcPts val="400"/>
               </a:spcAft>
-              <a:defRPr sz="1200">
+              <a:defRPr sz="1150">
                 <a:solidFill>
                   <a:srgbClr val="1E293B"/>
                 </a:solidFill>
@@ -3637,7 +3637,7 @@
               <a:spcAft>
                 <a:spcPts val="400"/>
               </a:spcAft>
-              <a:defRPr sz="1200">
+              <a:defRPr sz="1150">
                 <a:solidFill>
                   <a:srgbClr val="1E293B"/>
                 </a:solidFill>
@@ -3653,7 +3653,7 @@
               <a:spcAft>
                 <a:spcPts val="400"/>
               </a:spcAft>
-              <a:defRPr sz="1200">
+              <a:defRPr sz="1150">
                 <a:solidFill>
                   <a:srgbClr val="1E293B"/>
                 </a:solidFill>
@@ -3849,7 +3849,7 @@
               <a:spcAft>
                 <a:spcPts val="800"/>
               </a:spcAft>
-              <a:defRPr sz="1700" b="1">
+              <a:defRPr sz="1600" b="1">
                 <a:solidFill>
                   <a:srgbClr val="F59E0B"/>
                 </a:solidFill>
@@ -3865,7 +3865,7 @@
               <a:spcAft>
                 <a:spcPts val="400"/>
               </a:spcAft>
-              <a:defRPr sz="1200">
+              <a:defRPr sz="1150">
                 <a:solidFill>
                   <a:srgbClr val="1E293B"/>
                 </a:solidFill>
@@ -3881,7 +3881,7 @@
               <a:spcAft>
                 <a:spcPts val="400"/>
               </a:spcAft>
-              <a:defRPr sz="1200">
+              <a:defRPr sz="1150">
                 <a:solidFill>
                   <a:srgbClr val="1E293B"/>
                 </a:solidFill>
@@ -3897,7 +3897,7 @@
               <a:spcAft>
                 <a:spcPts val="400"/>
               </a:spcAft>
-              <a:defRPr sz="1200">
+              <a:defRPr sz="1150">
                 <a:solidFill>
                   <a:srgbClr val="1E293B"/>
                 </a:solidFill>
@@ -3913,7 +3913,7 @@
               <a:spcAft>
                 <a:spcPts val="400"/>
               </a:spcAft>
-              <a:defRPr sz="1200">
+              <a:defRPr sz="1150">
                 <a:solidFill>
                   <a:srgbClr val="1E293B"/>
                 </a:solidFill>
@@ -3929,7 +3929,7 @@
               <a:spcAft>
                 <a:spcPts val="400"/>
               </a:spcAft>
-              <a:defRPr sz="1200">
+              <a:defRPr sz="1150">
                 <a:solidFill>
                   <a:srgbClr val="1E293B"/>
                 </a:solidFill>
@@ -4013,7 +4013,7 @@
               <a:spcAft>
                 <a:spcPts val="800"/>
               </a:spcAft>
-              <a:defRPr sz="1700" b="1">
+              <a:defRPr sz="1600" b="1">
                 <a:solidFill>
                   <a:srgbClr val="0066FF"/>
                 </a:solidFill>
@@ -4029,7 +4029,7 @@
               <a:spcAft>
                 <a:spcPts val="400"/>
               </a:spcAft>
-              <a:defRPr sz="1200">
+              <a:defRPr sz="1150">
                 <a:solidFill>
                   <a:srgbClr val="1E293B"/>
                 </a:solidFill>
@@ -4045,7 +4045,7 @@
               <a:spcAft>
                 <a:spcPts val="400"/>
               </a:spcAft>
-              <a:defRPr sz="1200">
+              <a:defRPr sz="1150">
                 <a:solidFill>
                   <a:srgbClr val="1E293B"/>
                 </a:solidFill>
@@ -4061,7 +4061,7 @@
               <a:spcAft>
                 <a:spcPts val="400"/>
               </a:spcAft>
-              <a:defRPr sz="1200">
+              <a:defRPr sz="1150">
                 <a:solidFill>
                   <a:srgbClr val="1E293B"/>
                 </a:solidFill>
@@ -4077,7 +4077,7 @@
               <a:spcAft>
                 <a:spcPts val="400"/>
               </a:spcAft>
-              <a:defRPr sz="1200">
+              <a:defRPr sz="1150">
                 <a:solidFill>
                   <a:srgbClr val="1E293B"/>
                 </a:solidFill>
@@ -4273,7 +4273,7 @@
               <a:spcAft>
                 <a:spcPts val="800"/>
               </a:spcAft>
-              <a:defRPr sz="1700" b="1">
+              <a:defRPr sz="1600" b="1">
                 <a:solidFill>
                   <a:srgbClr val="10B981"/>
                 </a:solidFill>
@@ -4289,7 +4289,7 @@
               <a:spcAft>
                 <a:spcPts val="400"/>
               </a:spcAft>
-              <a:defRPr sz="1200">
+              <a:defRPr sz="1150">
                 <a:solidFill>
                   <a:srgbClr val="1E293B"/>
                 </a:solidFill>
@@ -4305,7 +4305,7 @@
               <a:spcAft>
                 <a:spcPts val="400"/>
               </a:spcAft>
-              <a:defRPr sz="1200">
+              <a:defRPr sz="1150">
                 <a:solidFill>
                   <a:srgbClr val="1E293B"/>
                 </a:solidFill>
@@ -4321,7 +4321,7 @@
               <a:spcAft>
                 <a:spcPts val="400"/>
               </a:spcAft>
-              <a:defRPr sz="1200">
+              <a:defRPr sz="1150">
                 <a:solidFill>
                   <a:srgbClr val="1E293B"/>
                 </a:solidFill>
@@ -4337,7 +4337,7 @@
               <a:spcAft>
                 <a:spcPts val="400"/>
               </a:spcAft>
-              <a:defRPr sz="1200">
+              <a:defRPr sz="1150">
                 <a:solidFill>
                   <a:srgbClr val="1E293B"/>
                 </a:solidFill>
@@ -4421,7 +4421,7 @@
               <a:spcAft>
                 <a:spcPts val="800"/>
               </a:spcAft>
-              <a:defRPr sz="1700" b="1">
+              <a:defRPr sz="1600" b="1">
                 <a:solidFill>
                   <a:srgbClr val="F59E0B"/>
                 </a:solidFill>
@@ -4437,7 +4437,7 @@
               <a:spcAft>
                 <a:spcPts val="400"/>
               </a:spcAft>
-              <a:defRPr sz="1200">
+              <a:defRPr sz="1150">
                 <a:solidFill>
                   <a:srgbClr val="1E293B"/>
                 </a:solidFill>
@@ -4453,7 +4453,7 @@
               <a:spcAft>
                 <a:spcPts val="400"/>
               </a:spcAft>
-              <a:defRPr sz="1200">
+              <a:defRPr sz="1150">
                 <a:solidFill>
                   <a:srgbClr val="1E293B"/>
                 </a:solidFill>
@@ -4469,7 +4469,7 @@
               <a:spcAft>
                 <a:spcPts val="400"/>
               </a:spcAft>
-              <a:defRPr sz="1200">
+              <a:defRPr sz="1150">
                 <a:solidFill>
                   <a:srgbClr val="1E293B"/>
                 </a:solidFill>
@@ -4485,7 +4485,7 @@
               <a:spcAft>
                 <a:spcPts val="400"/>
               </a:spcAft>
-              <a:defRPr sz="1200">
+              <a:defRPr sz="1150">
                 <a:solidFill>
                   <a:srgbClr val="1E293B"/>
                 </a:solidFill>
@@ -4681,7 +4681,7 @@
               <a:spcAft>
                 <a:spcPts val="800"/>
               </a:spcAft>
-              <a:defRPr sz="1700" b="1">
+              <a:defRPr sz="1600" b="1">
                 <a:solidFill>
                   <a:srgbClr val="0066FF"/>
                 </a:solidFill>
@@ -4697,15 +4697,15 @@
               <a:spcAft>
                 <a:spcPts val="400"/>
               </a:spcAft>
-              <a:defRPr sz="1200">
-                <a:solidFill>
-                  <a:srgbClr val="1E293B"/>
-                </a:solidFill>
-                <a:latin typeface="Calibri"/>
-              </a:defRPr>
-            </a:pPr>
-            <a:r>
-              <a:t>• 1. Relational Integrity: Foreign key constraints ensure data consistency across complex multi-table workflows.</a:t>
+              <a:defRPr sz="1150">
+                <a:solidFill>
+                  <a:srgbClr val="1E293B"/>
+                </a:solidFill>
+                <a:latin typeface="Calibri"/>
+              </a:defRPr>
+            </a:pPr>
+            <a:r>
+              <a:t>• 1. Sequential Data Flow: Data moves in 6 distinct steps from Inquiry to Job Placement.</a:t>
             </a:r>
           </a:p>
           <a:p>
@@ -4713,15 +4713,15 @@
               <a:spcAft>
                 <a:spcPts val="400"/>
               </a:spcAft>
-              <a:defRPr sz="1200">
-                <a:solidFill>
-                  <a:srgbClr val="1E293B"/>
-                </a:solidFill>
-                <a:latin typeface="Calibri"/>
-              </a:defRPr>
-            </a:pPr>
-            <a:r>
-              <a:t>• 2. Central Hub Pattern: 'users', 'batches', and 'courses' form the core backbone of all sub-modules.</a:t>
+              <a:defRPr sz="1150">
+                <a:solidFill>
+                  <a:srgbClr val="1E293B"/>
+                </a:solidFill>
+                <a:latin typeface="Calibri"/>
+              </a:defRPr>
+            </a:pPr>
+            <a:r>
+              <a:t>• 2. Table Transitions: Foreign keys (leadId, userId, batchId) connect tables sequentially.</a:t>
             </a:r>
           </a:p>
           <a:p>
@@ -4729,15 +4729,15 @@
               <a:spcAft>
                 <a:spcPts val="400"/>
               </a:spcAft>
-              <a:defRPr sz="1200">
-                <a:solidFill>
-                  <a:srgbClr val="1E293B"/>
-                </a:solidFill>
-                <a:latin typeface="Calibri"/>
-              </a:defRPr>
-            </a:pPr>
-            <a:r>
-              <a:t>• 3. Domain-Driven Analytics: Organizing database tables into functional domains simplifies dashboard design.</a:t>
+              <a:defRPr sz="1150">
+                <a:solidFill>
+                  <a:srgbClr val="1E293B"/>
+                </a:solidFill>
+                <a:latin typeface="Calibri"/>
+              </a:defRPr>
+            </a:pPr>
+            <a:r>
+              <a:t>• 3. Central Hub Pattern: 'users', 'batches', and 'courses' form the core backbone of all sub-modules.</a:t>
             </a:r>
           </a:p>
           <a:p>
@@ -4745,7 +4745,7 @@
               <a:spcAft>
                 <a:spcPts val="400"/>
               </a:spcAft>
-              <a:defRPr sz="1200">
+              <a:defRPr sz="1150">
                 <a:solidFill>
                   <a:srgbClr val="1E293B"/>
                 </a:solidFill>
@@ -4761,7 +4761,7 @@
               <a:spcAft>
                 <a:spcPts val="400"/>
               </a:spcAft>
-              <a:defRPr sz="1200">
+              <a:defRPr sz="1150">
                 <a:solidFill>
                   <a:srgbClr val="1E293B"/>
                 </a:solidFill>
@@ -4957,7 +4957,7 @@
               <a:spcAft>
                 <a:spcPts val="800"/>
               </a:spcAft>
-              <a:defRPr sz="1700" b="1">
+              <a:defRPr sz="1600" b="1">
                 <a:solidFill>
                   <a:srgbClr val="0066FF"/>
                 </a:solidFill>
@@ -4973,7 +4973,7 @@
               <a:spcAft>
                 <a:spcPts val="400"/>
               </a:spcAft>
-              <a:defRPr sz="1200">
+              <a:defRPr sz="1150">
                 <a:solidFill>
                   <a:srgbClr val="1E293B"/>
                 </a:solidFill>
@@ -4989,7 +4989,7 @@
               <a:spcAft>
                 <a:spcPts val="400"/>
               </a:spcAft>
-              <a:defRPr sz="1200">
+              <a:defRPr sz="1150">
                 <a:solidFill>
                   <a:srgbClr val="1E293B"/>
                 </a:solidFill>
@@ -5005,7 +5005,7 @@
               <a:spcAft>
                 <a:spcPts val="400"/>
               </a:spcAft>
-              <a:defRPr sz="1200">
+              <a:defRPr sz="1150">
                 <a:solidFill>
                   <a:srgbClr val="1E293B"/>
                 </a:solidFill>
@@ -5021,7 +5021,7 @@
               <a:spcAft>
                 <a:spcPts val="400"/>
               </a:spcAft>
-              <a:defRPr sz="1200">
+              <a:defRPr sz="1150">
                 <a:solidFill>
                   <a:srgbClr val="1E293B"/>
                 </a:solidFill>
@@ -5105,7 +5105,7 @@
               <a:spcAft>
                 <a:spcPts val="800"/>
               </a:spcAft>
-              <a:defRPr sz="1700" b="1">
+              <a:defRPr sz="1600" b="1">
                 <a:solidFill>
                   <a:srgbClr val="F59E0B"/>
                 </a:solidFill>
@@ -5121,7 +5121,7 @@
               <a:spcAft>
                 <a:spcPts val="400"/>
               </a:spcAft>
-              <a:defRPr sz="1200">
+              <a:defRPr sz="1150">
                 <a:solidFill>
                   <a:srgbClr val="1E293B"/>
                 </a:solidFill>
@@ -5137,7 +5137,7 @@
               <a:spcAft>
                 <a:spcPts val="400"/>
               </a:spcAft>
-              <a:defRPr sz="1200">
+              <a:defRPr sz="1150">
                 <a:solidFill>
                   <a:srgbClr val="1E293B"/>
                 </a:solidFill>
@@ -5153,7 +5153,7 @@
               <a:spcAft>
                 <a:spcPts val="400"/>
               </a:spcAft>
-              <a:defRPr sz="1200">
+              <a:defRPr sz="1150">
                 <a:solidFill>
                   <a:srgbClr val="1E293B"/>
                 </a:solidFill>
@@ -5169,7 +5169,7 @@
               <a:spcAft>
                 <a:spcPts val="400"/>
               </a:spcAft>
-              <a:defRPr sz="1200">
+              <a:defRPr sz="1150">
                 <a:solidFill>
                   <a:srgbClr val="1E293B"/>
                 </a:solidFill>
@@ -5185,7 +5185,7 @@
               <a:spcAft>
                 <a:spcPts val="400"/>
               </a:spcAft>
-              <a:defRPr sz="1200">
+              <a:defRPr sz="1150">
                 <a:solidFill>
                   <a:srgbClr val="1E293B"/>
                 </a:solidFill>
@@ -5292,7 +5292,7 @@
               </a:defRPr>
             </a:pPr>
             <a:r>
-              <a:t>2. End-to-End Student Lifecycle Data Pipeline</a:t>
+              <a:t>2. Complete Step-by-Step Table Data Flow Diagram</a:t>
             </a:r>
           </a:p>
           <a:p>
@@ -5305,7 +5305,7 @@
               </a:defRPr>
             </a:pPr>
             <a:r>
-              <a:t>5 Key Phases of Data Generation in an Enterprise LMS</a:t>
+              <a:t>How Data Flows sequentially through Database Tables in 6 Business Steps</a:t>
             </a:r>
           </a:p>
         </p:txBody>
@@ -5319,7 +5319,7 @@
         <p:spPr>
           <a:xfrm>
             <a:off x="731520" y="1463040"/>
-            <a:ext cx="2011680" cy="4754880"/>
+            <a:ext cx="1600200" cy="4754880"/>
           </a:xfrm>
           <a:prstGeom prst="roundRect">
             <a:avLst/>
@@ -5327,9 +5327,9 @@
           <a:solidFill>
             <a:srgbClr val="FFFFFF"/>
           </a:solidFill>
-          <a:ln w="19050">
+          <a:ln w="25400">
             <a:solidFill>
-              <a:srgbClr val="E2E8F0"/>
+              <a:srgbClr val="0066FF"/>
             </a:solidFill>
           </a:ln>
         </p:spPr>
@@ -5363,8 +5363,8 @@
         </p:nvSpPr>
         <p:spPr>
           <a:xfrm>
-            <a:off x="914400" y="1600200"/>
-            <a:ext cx="1645920" cy="4480560"/>
+            <a:off x="822960" y="1600200"/>
+            <a:ext cx="1417320" cy="4480560"/>
           </a:xfrm>
           <a:prstGeom prst="rect">
             <a:avLst/>
@@ -5377,11 +5377,8 @@
           </a:bodyPr>
           <a:lstStyle/>
           <a:p>
-            <a:pPr>
-              <a:spcAft>
-                <a:spcPts val="800"/>
-              </a:spcAft>
-              <a:defRPr sz="1700" b="1">
+            <a:pPr algn="ctr">
+              <a:defRPr sz="1300" b="1">
                 <a:solidFill>
                   <a:srgbClr val="0066FF"/>
                 </a:solidFill>
@@ -5389,55 +5386,43 @@
               </a:defRPr>
             </a:pPr>
             <a:r>
-              <a:t>Phase 1: Marketing</a:t>
-            </a:r>
-          </a:p>
-          <a:p>
-            <a:pPr>
-              <a:spcAft>
-                <a:spcPts val="400"/>
-              </a:spcAft>
-              <a:defRPr sz="1200">
-                <a:solidFill>
-                  <a:srgbClr val="1E293B"/>
-                </a:solidFill>
-                <a:latin typeface="Calibri"/>
-              </a:defRPr>
-            </a:pPr>
-            <a:r>
-              <a:t>• Lead capture from Ads</a:t>
-            </a:r>
-          </a:p>
-          <a:p>
-            <a:pPr>
-              <a:spcAft>
-                <a:spcPts val="400"/>
-              </a:spcAft>
-              <a:defRPr sz="1200">
-                <a:solidFill>
-                  <a:srgbClr val="1E293B"/>
-                </a:solidFill>
-                <a:latin typeface="Calibri"/>
-              </a:defRPr>
-            </a:pPr>
-            <a:r>
-              <a:t>• Call/Email logs</a:t>
-            </a:r>
-          </a:p>
-          <a:p>
-            <a:pPr>
-              <a:spcAft>
-                <a:spcPts val="400"/>
-              </a:spcAft>
-              <a:defRPr sz="1200">
-                <a:solidFill>
-                  <a:srgbClr val="1E293B"/>
-                </a:solidFill>
-                <a:latin typeface="Calibri"/>
-              </a:defRPr>
-            </a:pPr>
-            <a:r>
-              <a:t>• Lead to Student</a:t>
+              <a:t>1. INQUIRY</a:t>
+            </a:r>
+          </a:p>
+          <a:p>
+            <a:br/>
+            <a:pPr algn="ctr">
+              <a:defRPr sz="1100" b="1">
+                <a:solidFill>
+                  <a:srgbClr val="0F172A"/>
+                </a:solidFill>
+                <a:latin typeface="Calibri"/>
+              </a:defRPr>
+            </a:pPr>
+            <a:r>
+              <a:t>[ Tables ]</a:t>
+            </a:r>
+            <a:br/>
+            <a:r>
+              <a:t>leads</a:t>
+            </a:r>
+            <a:br/>
+            <a:r>
+              <a:t>lead_activities</a:t>
+            </a:r>
+          </a:p>
+          <a:p>
+            <a:br/>
+            <a:pPr algn="ctr">
+              <a:defRPr sz="1050">
+                <a:solidFill>
+                  <a:srgbClr val="1E293B"/>
+                </a:solidFill>
+                <a:latin typeface="Calibri"/>
+              </a:defRPr>
+            </a:pPr>
+            <a:r>
+              <a:t>Prospect registers interest. Calls &amp; emails logged.</a:t>
             </a:r>
           </a:p>
         </p:txBody>
@@ -5450,8 +5435,8 @@
         </p:nvSpPr>
         <p:spPr>
           <a:xfrm>
-            <a:off x="2926080" y="1463040"/>
-            <a:ext cx="2011680" cy="4754880"/>
+            <a:off x="2514600" y="1463040"/>
+            <a:ext cx="1600200" cy="4754880"/>
           </a:xfrm>
           <a:prstGeom prst="roundRect">
             <a:avLst/>
@@ -5459,9 +5444,9 @@
           <a:solidFill>
             <a:srgbClr val="FFFFFF"/>
           </a:solidFill>
-          <a:ln w="19050">
+          <a:ln w="25400">
             <a:solidFill>
-              <a:srgbClr val="E2E8F0"/>
+              <a:srgbClr val="F59E0B"/>
             </a:solidFill>
           </a:ln>
         </p:spPr>
@@ -5495,8 +5480,8 @@
         </p:nvSpPr>
         <p:spPr>
           <a:xfrm>
-            <a:off x="3108960" y="1600200"/>
-            <a:ext cx="1645920" cy="4480560"/>
+            <a:off x="2606040" y="1600200"/>
+            <a:ext cx="1417320" cy="4480560"/>
           </a:xfrm>
           <a:prstGeom prst="rect">
             <a:avLst/>
@@ -5509,11 +5494,8 @@
           </a:bodyPr>
           <a:lstStyle/>
           <a:p>
-            <a:pPr>
-              <a:spcAft>
-                <a:spcPts val="800"/>
-              </a:spcAft>
-              <a:defRPr sz="1700" b="1">
+            <a:pPr algn="ctr">
+              <a:defRPr sz="1300" b="1">
                 <a:solidFill>
                   <a:srgbClr val="F59E0B"/>
                 </a:solidFill>
@@ -5521,55 +5503,43 @@
               </a:defRPr>
             </a:pPr>
             <a:r>
-              <a:t>Phase 2: Finance</a:t>
-            </a:r>
-          </a:p>
-          <a:p>
-            <a:pPr>
-              <a:spcAft>
-                <a:spcPts val="400"/>
-              </a:spcAft>
-              <a:defRPr sz="1200">
-                <a:solidFill>
-                  <a:srgbClr val="1E293B"/>
-                </a:solidFill>
-                <a:latin typeface="Calibri"/>
-              </a:defRPr>
-            </a:pPr>
-            <a:r>
-              <a:t>• Course/Batch selection</a:t>
-            </a:r>
-          </a:p>
-          <a:p>
-            <a:pPr>
-              <a:spcAft>
-                <a:spcPts val="400"/>
-              </a:spcAft>
-              <a:defRPr sz="1200">
-                <a:solidFill>
-                  <a:srgbClr val="1E293B"/>
-                </a:solidFill>
-                <a:latin typeface="Calibri"/>
-              </a:defRPr>
-            </a:pPr>
-            <a:r>
-              <a:t>• Tuition fee tracking</a:t>
-            </a:r>
-          </a:p>
-          <a:p>
-            <a:pPr>
-              <a:spcAft>
-                <a:spcPts val="400"/>
-              </a:spcAft>
-              <a:defRPr sz="1200">
-                <a:solidFill>
-                  <a:srgbClr val="1E293B"/>
-                </a:solidFill>
-                <a:latin typeface="Calibri"/>
-              </a:defRPr>
-            </a:pPr>
-            <a:r>
-              <a:t>• Receipt &amp; verification</a:t>
+              <a:t>2. ADMISSION</a:t>
+            </a:r>
+          </a:p>
+          <a:p>
+            <a:br/>
+            <a:pPr algn="ctr">
+              <a:defRPr sz="1100" b="1">
+                <a:solidFill>
+                  <a:srgbClr val="0F172A"/>
+                </a:solidFill>
+                <a:latin typeface="Calibri"/>
+              </a:defRPr>
+            </a:pPr>
+            <a:r>
+              <a:t>[ Tables ]</a:t>
+            </a:r>
+            <a:br/>
+            <a:r>
+              <a:t>users</a:t>
+            </a:r>
+            <a:br/>
+            <a:r>
+              <a:t>registrations</a:t>
+            </a:r>
+          </a:p>
+          <a:p>
+            <a:br/>
+            <a:pPr algn="ctr">
+              <a:defRPr sz="1050">
+                <a:solidFill>
+                  <a:srgbClr val="1E293B"/>
+                </a:solidFill>
+                <a:latin typeface="Calibri"/>
+              </a:defRPr>
+            </a:pPr>
+            <a:r>
+              <a:t>Lead converts to User. Fee payment recorded.</a:t>
             </a:r>
           </a:p>
         </p:txBody>
@@ -5582,8 +5552,8 @@
         </p:nvSpPr>
         <p:spPr>
           <a:xfrm>
-            <a:off x="5120640" y="1463040"/>
-            <a:ext cx="2011680" cy="4754880"/>
+            <a:off x="4297680" y="1463040"/>
+            <a:ext cx="1600200" cy="4754880"/>
           </a:xfrm>
           <a:prstGeom prst="roundRect">
             <a:avLst/>
@@ -5591,9 +5561,9 @@
           <a:solidFill>
             <a:srgbClr val="FFFFFF"/>
           </a:solidFill>
-          <a:ln w="19050">
+          <a:ln w="25400">
             <a:solidFill>
-              <a:srgbClr val="E2E8F0"/>
+              <a:srgbClr val="10B981"/>
             </a:solidFill>
           </a:ln>
         </p:spPr>
@@ -5627,8 +5597,8 @@
         </p:nvSpPr>
         <p:spPr>
           <a:xfrm>
-            <a:off x="5303520" y="1600200"/>
-            <a:ext cx="1645920" cy="4480560"/>
+            <a:off x="4389120" y="1600200"/>
+            <a:ext cx="1417320" cy="4480560"/>
           </a:xfrm>
           <a:prstGeom prst="rect">
             <a:avLst/>
@@ -5641,11 +5611,8 @@
           </a:bodyPr>
           <a:lstStyle/>
           <a:p>
-            <a:pPr>
-              <a:spcAft>
-                <a:spcPts val="800"/>
-              </a:spcAft>
-              <a:defRPr sz="1700" b="1">
+            <a:pPr algn="ctr">
+              <a:defRPr sz="1300" b="1">
                 <a:solidFill>
                   <a:srgbClr val="10B981"/>
                 </a:solidFill>
@@ -5653,55 +5620,43 @@
               </a:defRPr>
             </a:pPr>
             <a:r>
-              <a:t>Phase 3: Operations</a:t>
-            </a:r>
-          </a:p>
-          <a:p>
-            <a:pPr>
-              <a:spcAft>
-                <a:spcPts val="400"/>
-              </a:spcAft>
-              <a:defRPr sz="1200">
-                <a:solidFill>
-                  <a:srgbClr val="1E293B"/>
-                </a:solidFill>
-                <a:latin typeface="Calibri"/>
-              </a:defRPr>
-            </a:pPr>
-            <a:r>
-              <a:t>• Daily QR attendance</a:t>
-            </a:r>
-          </a:p>
-          <a:p>
-            <a:pPr>
-              <a:spcAft>
-                <a:spcPts val="400"/>
-              </a:spcAft>
-              <a:defRPr sz="1200">
-                <a:solidFill>
-                  <a:srgbClr val="1E293B"/>
-                </a:solidFill>
-                <a:latin typeface="Calibri"/>
-              </a:defRPr>
-            </a:pPr>
-            <a:r>
-              <a:t>• Portal time logs</a:t>
-            </a:r>
-          </a:p>
-          <a:p>
-            <a:pPr>
-              <a:spcAft>
-                <a:spcPts val="400"/>
-              </a:spcAft>
-              <a:defRPr sz="1200">
-                <a:solidFill>
-                  <a:srgbClr val="1E293B"/>
-                </a:solidFill>
-                <a:latin typeface="Calibri"/>
-              </a:defRPr>
-            </a:pPr>
-            <a:r>
-              <a:t>• Leave quota audit</a:t>
+              <a:t>3. COHORT</a:t>
+            </a:r>
+          </a:p>
+          <a:p>
+            <a:br/>
+            <a:pPr algn="ctr">
+              <a:defRPr sz="1100" b="1">
+                <a:solidFill>
+                  <a:srgbClr val="0F172A"/>
+                </a:solidFill>
+                <a:latin typeface="Calibri"/>
+              </a:defRPr>
+            </a:pPr>
+            <a:r>
+              <a:t>[ Tables ]</a:t>
+            </a:r>
+            <a:br/>
+            <a:r>
+              <a:t>courses, batches</a:t>
+            </a:r>
+            <a:br/>
+            <a:r>
+              <a:t>batch_students</a:t>
+            </a:r>
+          </a:p>
+          <a:p>
+            <a:br/>
+            <a:pPr algn="ctr">
+              <a:defRPr sz="1050">
+                <a:solidFill>
+                  <a:srgbClr val="1E293B"/>
+                </a:solidFill>
+                <a:latin typeface="Calibri"/>
+              </a:defRPr>
+            </a:pPr>
+            <a:r>
+              <a:t>Student assigned to course batch cohort.</a:t>
             </a:r>
           </a:p>
         </p:txBody>
@@ -5714,8 +5669,8 @@
         </p:nvSpPr>
         <p:spPr>
           <a:xfrm>
-            <a:off x="7315200" y="1463040"/>
-            <a:ext cx="2011680" cy="4754880"/>
+            <a:off x="6080759" y="1463040"/>
+            <a:ext cx="1600200" cy="4754880"/>
           </a:xfrm>
           <a:prstGeom prst="roundRect">
             <a:avLst/>
@@ -5723,9 +5678,9 @@
           <a:solidFill>
             <a:srgbClr val="FFFFFF"/>
           </a:solidFill>
-          <a:ln w="19050">
+          <a:ln w="25400">
             <a:solidFill>
-              <a:srgbClr val="E2E8F0"/>
+              <a:srgbClr val="0066FF"/>
             </a:solidFill>
           </a:ln>
         </p:spPr>
@@ -5759,8 +5714,8 @@
         </p:nvSpPr>
         <p:spPr>
           <a:xfrm>
-            <a:off x="7498080" y="1600200"/>
-            <a:ext cx="1645920" cy="4480560"/>
+            <a:off x="6172199" y="1600200"/>
+            <a:ext cx="1417320" cy="4480560"/>
           </a:xfrm>
           <a:prstGeom prst="rect">
             <a:avLst/>
@@ -5773,11 +5728,8 @@
           </a:bodyPr>
           <a:lstStyle/>
           <a:p>
-            <a:pPr>
-              <a:spcAft>
-                <a:spcPts val="800"/>
-              </a:spcAft>
-              <a:defRPr sz="1700" b="1">
+            <a:pPr algn="ctr">
+              <a:defRPr sz="1300" b="1">
                 <a:solidFill>
                   <a:srgbClr val="0066FF"/>
                 </a:solidFill>
@@ -5785,55 +5737,43 @@
               </a:defRPr>
             </a:pPr>
             <a:r>
-              <a:t>Phase 4: Learning</a:t>
-            </a:r>
-          </a:p>
-          <a:p>
-            <a:pPr>
-              <a:spcAft>
-                <a:spcPts val="400"/>
-              </a:spcAft>
-              <a:defRPr sz="1200">
-                <a:solidFill>
-                  <a:srgbClr val="1E293B"/>
-                </a:solidFill>
-                <a:latin typeface="Calibri"/>
-              </a:defRPr>
-            </a:pPr>
-            <a:r>
-              <a:t>• Project/Task ticketing</a:t>
-            </a:r>
-          </a:p>
-          <a:p>
-            <a:pPr>
-              <a:spcAft>
-                <a:spcPts val="400"/>
-              </a:spcAft>
-              <a:defRPr sz="1200">
-                <a:solidFill>
-                  <a:srgbClr val="1E293B"/>
-                </a:solidFill>
-                <a:latin typeface="Calibri"/>
-              </a:defRPr>
-            </a:pPr>
-            <a:r>
-              <a:t>• Video lecture views</a:t>
-            </a:r>
-          </a:p>
-          <a:p>
-            <a:pPr>
-              <a:spcAft>
-                <a:spcPts val="400"/>
-              </a:spcAft>
-              <a:defRPr sz="1200">
-                <a:solidFill>
-                  <a:srgbClr val="1E293B"/>
-                </a:solidFill>
-                <a:latin typeface="Calibri"/>
-              </a:defRPr>
-            </a:pPr>
-            <a:r>
-              <a:t>• Tests &amp; feedback</a:t>
+              <a:t>4. DAILY OPS</a:t>
+            </a:r>
+          </a:p>
+          <a:p>
+            <a:br/>
+            <a:pPr algn="ctr">
+              <a:defRPr sz="1100" b="1">
+                <a:solidFill>
+                  <a:srgbClr val="0F172A"/>
+                </a:solidFill>
+                <a:latin typeface="Calibri"/>
+              </a:defRPr>
+            </a:pPr>
+            <a:r>
+              <a:t>[ Tables ]</a:t>
+            </a:r>
+            <a:br/>
+            <a:r>
+              <a:t>attendance</a:t>
+            </a:r>
+            <a:br/>
+            <a:r>
+              <a:t>time_tracking</a:t>
+            </a:r>
+          </a:p>
+          <a:p>
+            <a:br/>
+            <a:pPr algn="ctr">
+              <a:defRPr sz="1050">
+                <a:solidFill>
+                  <a:srgbClr val="1E293B"/>
+                </a:solidFill>
+                <a:latin typeface="Calibri"/>
+              </a:defRPr>
+            </a:pPr>
+            <a:r>
+              <a:t>Daily QR login hours &amp; portal time logged.</a:t>
             </a:r>
           </a:p>
         </p:txBody>
@@ -5846,8 +5786,8 @@
         </p:nvSpPr>
         <p:spPr>
           <a:xfrm>
-            <a:off x="9509760" y="1463040"/>
-            <a:ext cx="2011680" cy="4754880"/>
+            <a:off x="7863840" y="1463040"/>
+            <a:ext cx="1600200" cy="4754880"/>
           </a:xfrm>
           <a:prstGeom prst="roundRect">
             <a:avLst/>
@@ -5855,9 +5795,9 @@
           <a:solidFill>
             <a:srgbClr val="FFFFFF"/>
           </a:solidFill>
-          <a:ln w="19050">
+          <a:ln w="25400">
             <a:solidFill>
-              <a:srgbClr val="E2E8F0"/>
+              <a:srgbClr val="9333EA"/>
             </a:solidFill>
           </a:ln>
         </p:spPr>
@@ -5891,8 +5831,8 @@
         </p:nvSpPr>
         <p:spPr>
           <a:xfrm>
-            <a:off x="9692640" y="1600200"/>
-            <a:ext cx="1645920" cy="4480560"/>
+            <a:off x="7955279" y="1600200"/>
+            <a:ext cx="1417320" cy="4480560"/>
           </a:xfrm>
           <a:prstGeom prst="rect">
             <a:avLst/>
@@ -5905,11 +5845,125 @@
           </a:bodyPr>
           <a:lstStyle/>
           <a:p>
-            <a:pPr>
-              <a:spcAft>
-                <a:spcPts val="800"/>
-              </a:spcAft>
-              <a:defRPr sz="1700" b="1">
+            <a:pPr algn="ctr">
+              <a:defRPr sz="1300" b="1">
+                <a:solidFill>
+                  <a:srgbClr val="9333EA"/>
+                </a:solidFill>
+                <a:latin typeface="Calibri"/>
+              </a:defRPr>
+            </a:pPr>
+            <a:r>
+              <a:t>5. LEARNING</a:t>
+            </a:r>
+          </a:p>
+          <a:p>
+            <a:br/>
+            <a:pPr algn="ctr">
+              <a:defRPr sz="1100" b="1">
+                <a:solidFill>
+                  <a:srgbClr val="0F172A"/>
+                </a:solidFill>
+                <a:latin typeface="Calibri"/>
+              </a:defRPr>
+            </a:pPr>
+            <a:r>
+              <a:t>[ Tables ]</a:t>
+            </a:r>
+            <a:br/>
+            <a:r>
+              <a:t>projects, tasks</a:t>
+            </a:r>
+            <a:br/>
+            <a:r>
+              <a:t>assessments</a:t>
+            </a:r>
+          </a:p>
+          <a:p>
+            <a:br/>
+            <a:pPr algn="ctr">
+              <a:defRPr sz="1050">
+                <a:solidFill>
+                  <a:srgbClr val="1E293B"/>
+                </a:solidFill>
+                <a:latin typeface="Calibri"/>
+              </a:defRPr>
+            </a:pPr>
+            <a:r>
+              <a:t>Tasks submitted, exams scored, feedback recorded.</a:t>
+            </a:r>
+          </a:p>
+        </p:txBody>
+      </p:sp>
+      <p:sp>
+        <p:nvSpPr>
+          <p:cNvPr id="14" name="Rounded Rectangle 13"/>
+          <p:cNvSpPr/>
+          <p:nvPr/>
+        </p:nvSpPr>
+        <p:spPr>
+          <a:xfrm>
+            <a:off x="9646920" y="1463040"/>
+            <a:ext cx="1600200" cy="4754880"/>
+          </a:xfrm>
+          <a:prstGeom prst="roundRect">
+            <a:avLst/>
+          </a:prstGeom>
+          <a:solidFill>
+            <a:srgbClr val="FFFFFF"/>
+          </a:solidFill>
+          <a:ln w="25400">
+            <a:solidFill>
+              <a:srgbClr val="F59E0B"/>
+            </a:solidFill>
+          </a:ln>
+        </p:spPr>
+        <p:style>
+          <a:lnRef idx="1">
+            <a:schemeClr val="accent1"/>
+          </a:lnRef>
+          <a:fillRef idx="3">
+            <a:schemeClr val="accent1"/>
+          </a:fillRef>
+          <a:effectRef idx="2">
+            <a:schemeClr val="accent1"/>
+          </a:effectRef>
+          <a:fontRef idx="minor">
+            <a:schemeClr val="lt1"/>
+          </a:fontRef>
+        </p:style>
+        <p:txBody>
+          <a:bodyPr rtlCol="0" anchor="ctr"/>
+          <a:lstStyle/>
+          <a:p>
+            <a:pPr algn="ctr"/>
+          </a:p>
+        </p:txBody>
+      </p:sp>
+      <p:sp>
+        <p:nvSpPr>
+          <p:cNvPr id="15" name="TextBox 14"/>
+          <p:cNvSpPr txBox="1"/>
+          <p:nvPr/>
+        </p:nvSpPr>
+        <p:spPr>
+          <a:xfrm>
+            <a:off x="9738360" y="1600200"/>
+            <a:ext cx="1417320" cy="4480560"/>
+          </a:xfrm>
+          <a:prstGeom prst="rect">
+            <a:avLst/>
+          </a:prstGeom>
+          <a:noFill/>
+        </p:spPr>
+        <p:txBody>
+          <a:bodyPr wrap="square">
+            <a:spAutoFit/>
+          </a:bodyPr>
+          <a:lstStyle/>
+          <a:p>
+            <a:pPr algn="ctr">
+              <a:defRPr sz="1300" b="1">
                 <a:solidFill>
                   <a:srgbClr val="F59E0B"/>
                 </a:solidFill>
@@ -5917,55 +5971,43 @@
               </a:defRPr>
             </a:pPr>
             <a:r>
-              <a:t>Phase 5: Placement</a:t>
-            </a:r>
-          </a:p>
-          <a:p>
-            <a:pPr>
-              <a:spcAft>
-                <a:spcPts val="400"/>
-              </a:spcAft>
-              <a:defRPr sz="1200">
-                <a:solidFill>
-                  <a:srgbClr val="1E293B"/>
-                </a:solidFill>
-                <a:latin typeface="Calibri"/>
-              </a:defRPr>
-            </a:pPr>
-            <a:r>
-              <a:t>• Mock interview scores</a:t>
-            </a:r>
-          </a:p>
-          <a:p>
-            <a:pPr>
-              <a:spcAft>
-                <a:spcPts val="400"/>
-              </a:spcAft>
-              <a:defRPr sz="1200">
-                <a:solidFill>
-                  <a:srgbClr val="1E293B"/>
-                </a:solidFill>
-                <a:latin typeface="Calibri"/>
-              </a:defRPr>
-            </a:pPr>
-            <a:r>
-              <a:t>• Verbal drills</a:t>
-            </a:r>
-          </a:p>
-          <a:p>
-            <a:pPr>
-              <a:spcAft>
-                <a:spcPts val="400"/>
-              </a:spcAft>
-              <a:defRPr sz="1200">
-                <a:solidFill>
-                  <a:srgbClr val="1E293B"/>
-                </a:solidFill>
-                <a:latin typeface="Calibri"/>
-              </a:defRPr>
-            </a:pPr>
-            <a:r>
-              <a:t>• Job application funnel</a:t>
+              <a:t>6. CAREER</a:t>
+            </a:r>
+          </a:p>
+          <a:p>
+            <a:br/>
+            <a:pPr algn="ctr">
+              <a:defRPr sz="1100" b="1">
+                <a:solidFill>
+                  <a:srgbClr val="0F172A"/>
+                </a:solidFill>
+                <a:latin typeface="Calibri"/>
+              </a:defRPr>
+            </a:pPr>
+            <a:r>
+              <a:t>[ Tables ]</a:t>
+            </a:r>
+            <a:br/>
+            <a:r>
+              <a:t>mock_interviews</a:t>
+            </a:r>
+            <a:br/>
+            <a:r>
+              <a:t>job_applications</a:t>
+            </a:r>
+          </a:p>
+          <a:p>
+            <a:br/>
+            <a:pPr algn="ctr">
+              <a:defRPr sz="1050">
+                <a:solidFill>
+                  <a:srgbClr val="1E293B"/>
+                </a:solidFill>
+                <a:latin typeface="Calibri"/>
+              </a:defRPr>
+            </a:pPr>
+            <a:r>
+              <a:t>Mock scores logged &amp; job selection tracked.</a:t>
             </a:r>
           </a:p>
         </p:txBody>
@@ -6064,7 +6106,7 @@
               </a:defRPr>
             </a:pPr>
             <a:r>
-              <a:t>3. System Roles &amp; Access Matrix</a:t>
+              <a:t>3. Table-to-Table Data Transition Pipeline</a:t>
             </a:r>
           </a:p>
           <a:p>
@@ -6077,7 +6119,7 @@
               </a:defRPr>
             </a:pPr>
             <a:r>
-              <a:t>Role-Based Access Control (RBAC) &amp; Data Access Boundaries</a:t>
+              <a:t>Data Inputs &amp; Outputs Passing Between Interconnected Database Tables</a:t>
             </a:r>
           </a:p>
         </p:txBody>
@@ -6090,8 +6132,8 @@
         </p:nvSpPr>
         <p:spPr>
           <a:xfrm>
-            <a:off x="731520" y="1463040"/>
-            <a:ext cx="10728655" cy="1051560"/>
+            <a:off x="731520" y="1371600"/>
+            <a:ext cx="10728655" cy="868680"/>
           </a:xfrm>
           <a:prstGeom prst="roundRect">
             <a:avLst/>
@@ -6135,8 +6177,8 @@
         </p:nvSpPr>
         <p:spPr>
           <a:xfrm>
-            <a:off x="914400" y="1600200"/>
-            <a:ext cx="10332720" cy="777240"/>
+            <a:off x="914400" y="1444752"/>
+            <a:ext cx="10332720" cy="731520"/>
           </a:xfrm>
           <a:prstGeom prst="rect">
             <a:avLst/>
@@ -6150,7 +6192,7 @@
           <a:lstStyle/>
           <a:p>
             <a:pPr>
-              <a:defRPr sz="1700" b="1">
+              <a:defRPr sz="1400" b="1">
                 <a:solidFill>
                   <a:srgbClr val="0066FF"/>
                 </a:solidFill>
@@ -6158,20 +6200,20 @@
               </a:defRPr>
             </a:pPr>
             <a:r>
-              <a:t>SUPER_ADMIN / ADMIN</a:t>
-            </a:r>
-          </a:p>
-          <a:p>
-            <a:pPr>
-              <a:defRPr sz="1300">
-                <a:solidFill>
-                  <a:srgbClr val="1E293B"/>
-                </a:solidFill>
-                <a:latin typeface="Calibri"/>
-              </a:defRPr>
-            </a:pPr>
-            <a:r>
-              <a:t>Full system governance, course/batch creation, fee setup, leave approvals, user permissions</a:t>
+              <a:t>Input Stage 1: Lead Capture   |   leads (leadId) ➔ lead_activities (activityId)</a:t>
+            </a:r>
+          </a:p>
+          <a:p>
+            <a:pPr>
+              <a:defRPr sz="1150">
+                <a:solidFill>
+                  <a:srgbClr val="1E293B"/>
+                </a:solidFill>
+                <a:latin typeface="Calibri"/>
+              </a:defRPr>
+            </a:pPr>
+            <a:r>
+              <a:t>Marketers capture lead details. Every call/email adds a row in lead_activities referencing leadId.</a:t>
             </a:r>
           </a:p>
         </p:txBody>
@@ -6184,8 +6226,8 @@
         </p:nvSpPr>
         <p:spPr>
           <a:xfrm>
-            <a:off x="731520" y="2697480"/>
-            <a:ext cx="10728655" cy="1051560"/>
+            <a:off x="731520" y="2377440"/>
+            <a:ext cx="10728655" cy="868680"/>
           </a:xfrm>
           <a:prstGeom prst="roundRect">
             <a:avLst/>
@@ -6229,8 +6271,8 @@
         </p:nvSpPr>
         <p:spPr>
           <a:xfrm>
-            <a:off x="914400" y="2834640"/>
-            <a:ext cx="10332720" cy="777240"/>
+            <a:off x="914400" y="2450592"/>
+            <a:ext cx="10332720" cy="731520"/>
           </a:xfrm>
           <a:prstGeom prst="rect">
             <a:avLst/>
@@ -6244,28 +6286,28 @@
           <a:lstStyle/>
           <a:p>
             <a:pPr>
-              <a:defRPr sz="1700" b="1">
-                <a:solidFill>
-                  <a:srgbClr val="10B981"/>
-                </a:solidFill>
-                <a:latin typeface="Calibri"/>
-              </a:defRPr>
-            </a:pPr>
-            <a:r>
-              <a:t>TRAINER</a:t>
-            </a:r>
-          </a:p>
-          <a:p>
-            <a:pPr>
-              <a:defRPr sz="1300">
-                <a:solidFill>
-                  <a:srgbClr val="1E293B"/>
-                </a:solidFill>
-                <a:latin typeface="Calibri"/>
-              </a:defRPr>
-            </a:pPr>
-            <a:r>
-              <a:t>Batch management, project/task assignment, attendance tracking, assessment grading</a:t>
+              <a:defRPr sz="1400" b="1">
+                <a:solidFill>
+                  <a:srgbClr val="F59E0B"/>
+                </a:solidFill>
+                <a:latin typeface="Calibri"/>
+              </a:defRPr>
+            </a:pPr>
+            <a:r>
+              <a:t>Transition Stage 2: Enrollment   |   leads ➔ users (userId) ➔ registrations</a:t>
+            </a:r>
+          </a:p>
+          <a:p>
+            <a:pPr>
+              <a:defRPr sz="1150">
+                <a:solidFill>
+                  <a:srgbClr val="1E293B"/>
+                </a:solidFill>
+                <a:latin typeface="Calibri"/>
+              </a:defRPr>
+            </a:pPr>
+            <a:r>
+              <a:t>When lead status changes to CONVERTED, a new record is created in users. Fees logged in registrations.</a:t>
             </a:r>
           </a:p>
         </p:txBody>
@@ -6278,8 +6320,8 @@
         </p:nvSpPr>
         <p:spPr>
           <a:xfrm>
-            <a:off x="731520" y="3931920"/>
-            <a:ext cx="10728655" cy="1051560"/>
+            <a:off x="731520" y="3383280"/>
+            <a:ext cx="10728655" cy="868680"/>
           </a:xfrm>
           <a:prstGeom prst="roundRect">
             <a:avLst/>
@@ -6323,8 +6365,8 @@
         </p:nvSpPr>
         <p:spPr>
           <a:xfrm>
-            <a:off x="914400" y="4069080"/>
-            <a:ext cx="10332720" cy="777240"/>
+            <a:off x="914400" y="3456432"/>
+            <a:ext cx="10332720" cy="731520"/>
           </a:xfrm>
           <a:prstGeom prst="rect">
             <a:avLst/>
@@ -6338,28 +6380,28 @@
           <a:lstStyle/>
           <a:p>
             <a:pPr>
-              <a:defRPr sz="1700" b="1">
-                <a:solidFill>
-                  <a:srgbClr val="F59E0B"/>
-                </a:solidFill>
-                <a:latin typeface="Calibri"/>
-              </a:defRPr>
-            </a:pPr>
-            <a:r>
-              <a:t>MARKETER</a:t>
-            </a:r>
-          </a:p>
-          <a:p>
-            <a:pPr>
-              <a:defRPr sz="1300">
-                <a:solidFill>
-                  <a:srgbClr val="1E293B"/>
-                </a:solidFill>
-                <a:latin typeface="Calibri"/>
-              </a:defRPr>
-            </a:pPr>
-            <a:r>
-              <a:t>Lead generation, prospect follow-ups (Calls/Emails/WhatsApp), registration conversion</a:t>
+              <a:defRPr sz="1400" b="1">
+                <a:solidFill>
+                  <a:srgbClr val="10B981"/>
+                </a:solidFill>
+                <a:latin typeface="Calibri"/>
+              </a:defRPr>
+            </a:pPr>
+            <a:r>
+              <a:t>Execution Stage 3: Training   |   users ➔ batch_students ➔ attendance &amp; tasks</a:t>
+            </a:r>
+          </a:p>
+          <a:p>
+            <a:pPr>
+              <a:defRPr sz="1150">
+                <a:solidFill>
+                  <a:srgbClr val="1E293B"/>
+                </a:solidFill>
+                <a:latin typeface="Calibri"/>
+              </a:defRPr>
+            </a:pPr>
+            <a:r>
+              <a:t>Student userId is mapped to batchId. Daily attendance logs &amp; task progress link to userId &amp; batchId.</a:t>
             </a:r>
           </a:p>
         </p:txBody>
@@ -6372,8 +6414,8 @@
         </p:nvSpPr>
         <p:spPr>
           <a:xfrm>
-            <a:off x="731520" y="5166360"/>
-            <a:ext cx="10728655" cy="1051560"/>
+            <a:off x="731520" y="4389120"/>
+            <a:ext cx="10728655" cy="868680"/>
           </a:xfrm>
           <a:prstGeom prst="roundRect">
             <a:avLst/>
@@ -6417,8 +6459,8 @@
         </p:nvSpPr>
         <p:spPr>
           <a:xfrm>
-            <a:off x="914400" y="5303520"/>
-            <a:ext cx="10332720" cy="777240"/>
+            <a:off x="914400" y="4462272"/>
+            <a:ext cx="10332720" cy="731520"/>
           </a:xfrm>
           <a:prstGeom prst="rect">
             <a:avLst/>
@@ -6432,28 +6474,122 @@
           <a:lstStyle/>
           <a:p>
             <a:pPr>
-              <a:defRPr sz="1700" b="1">
-                <a:solidFill>
-                  <a:srgbClr val="0066FF"/>
-                </a:solidFill>
-                <a:latin typeface="Calibri"/>
-              </a:defRPr>
-            </a:pPr>
-            <a:r>
-              <a:t>STUDENT</a:t>
-            </a:r>
-          </a:p>
-          <a:p>
-            <a:pPr>
-              <a:defRPr sz="1300">
-                <a:solidFill>
-                  <a:srgbClr val="1E293B"/>
-                </a:solidFill>
-                <a:latin typeface="Calibri"/>
-              </a:defRPr>
-            </a:pPr>
-            <a:r>
-              <a:t>Class attendance, portal time logging, assignment submissions, tests, job applications</a:t>
+              <a:defRPr sz="1400" b="1">
+                <a:solidFill>
+                  <a:srgbClr val="9333EA"/>
+                </a:solidFill>
+                <a:latin typeface="Calibri"/>
+              </a:defRPr>
+            </a:pPr>
+            <a:r>
+              <a:t>Evaluation Stage 4: Assessments   |   users ➔ assessment_submissions &amp; feedback</a:t>
+            </a:r>
+          </a:p>
+          <a:p>
+            <a:pPr>
+              <a:defRPr sz="1150">
+                <a:solidFill>
+                  <a:srgbClr val="1E293B"/>
+                </a:solidFill>
+                <a:latin typeface="Calibri"/>
+              </a:defRPr>
+            </a:pPr>
+            <a:r>
+              <a:t>Exams taken create records in assessment_submissions. Weekly ratings recorded in feedback table.</a:t>
+            </a:r>
+          </a:p>
+        </p:txBody>
+      </p:sp>
+      <p:sp>
+        <p:nvSpPr>
+          <p:cNvPr id="12" name="Rounded Rectangle 11"/>
+          <p:cNvSpPr/>
+          <p:nvPr/>
+        </p:nvSpPr>
+        <p:spPr>
+          <a:xfrm>
+            <a:off x="731520" y="5394960"/>
+            <a:ext cx="10728655" cy="868680"/>
+          </a:xfrm>
+          <a:prstGeom prst="roundRect">
+            <a:avLst/>
+          </a:prstGeom>
+          <a:solidFill>
+            <a:srgbClr val="FFFFFF"/>
+          </a:solidFill>
+          <a:ln w="19050">
+            <a:solidFill>
+              <a:srgbClr val="E2E8F0"/>
+            </a:solidFill>
+          </a:ln>
+        </p:spPr>
+        <p:style>
+          <a:lnRef idx="1">
+            <a:schemeClr val="accent1"/>
+          </a:lnRef>
+          <a:fillRef idx="3">
+            <a:schemeClr val="accent1"/>
+          </a:fillRef>
+          <a:effectRef idx="2">
+            <a:schemeClr val="accent1"/>
+          </a:effectRef>
+          <a:fontRef idx="minor">
+            <a:schemeClr val="lt1"/>
+          </a:fontRef>
+        </p:style>
+        <p:txBody>
+          <a:bodyPr rtlCol="0" anchor="ctr"/>
+          <a:lstStyle/>
+          <a:p>
+            <a:pPr algn="ctr"/>
+          </a:p>
+        </p:txBody>
+      </p:sp>
+      <p:sp>
+        <p:nvSpPr>
+          <p:cNvPr id="13" name="TextBox 12"/>
+          <p:cNvSpPr txBox="1"/>
+          <p:nvPr/>
+        </p:nvSpPr>
+        <p:spPr>
+          <a:xfrm>
+            <a:off x="914400" y="5468112"/>
+            <a:ext cx="10332720" cy="731520"/>
+          </a:xfrm>
+          <a:prstGeom prst="rect">
+            <a:avLst/>
+          </a:prstGeom>
+          <a:noFill/>
+        </p:spPr>
+        <p:txBody>
+          <a:bodyPr wrap="none">
+            <a:spAutoFit/>
+          </a:bodyPr>
+          <a:lstStyle/>
+          <a:p>
+            <a:pPr>
+              <a:defRPr sz="1400" b="1">
+                <a:solidFill>
+                  <a:srgbClr val="F59E0B"/>
+                </a:solidFill>
+                <a:latin typeface="Calibri"/>
+              </a:defRPr>
+            </a:pPr>
+            <a:r>
+              <a:t>Outcome Stage 5: Job Hiring   |   users ➔ mock_interviews ➔ job_applications</a:t>
+            </a:r>
+          </a:p>
+          <a:p>
+            <a:pPr>
+              <a:defRPr sz="1150">
+                <a:solidFill>
+                  <a:srgbClr val="1E293B"/>
+                </a:solidFill>
+                <a:latin typeface="Calibri"/>
+              </a:defRPr>
+            </a:pPr>
+            <a:r>
+              <a:t>Mock interviews prepare students. Job applications track status from APPLIED to SELECTED.</a:t>
             </a:r>
           </a:p>
         </p:txBody>
@@ -6641,7 +6777,7 @@
               <a:spcAft>
                 <a:spcPts val="800"/>
               </a:spcAft>
-              <a:defRPr sz="1700" b="1">
+              <a:defRPr sz="1600" b="1">
                 <a:solidFill>
                   <a:srgbClr val="0066FF"/>
                 </a:solidFill>
@@ -6661,7 +6797,7 @@
               <a:spcAft>
                 <a:spcPts val="400"/>
               </a:spcAft>
-              <a:defRPr sz="1200">
+              <a:defRPr sz="1150">
                 <a:solidFill>
                   <a:srgbClr val="1E293B"/>
                 </a:solidFill>
@@ -6677,7 +6813,7 @@
               <a:spcAft>
                 <a:spcPts val="400"/>
               </a:spcAft>
-              <a:defRPr sz="1200">
+              <a:defRPr sz="1150">
                 <a:solidFill>
                   <a:srgbClr val="1E293B"/>
                 </a:solidFill>
@@ -6693,7 +6829,7 @@
               <a:spcAft>
                 <a:spcPts val="400"/>
               </a:spcAft>
-              <a:defRPr sz="1200">
+              <a:defRPr sz="1150">
                 <a:solidFill>
                   <a:srgbClr val="1E293B"/>
                 </a:solidFill>
@@ -6709,7 +6845,7 @@
               <a:spcAft>
                 <a:spcPts val="400"/>
               </a:spcAft>
-              <a:defRPr sz="1200">
+              <a:defRPr sz="1150">
                 <a:solidFill>
                   <a:srgbClr val="1E293B"/>
                 </a:solidFill>
@@ -6725,7 +6861,7 @@
               <a:spcAft>
                 <a:spcPts val="400"/>
               </a:spcAft>
-              <a:defRPr sz="1200">
+              <a:defRPr sz="1150">
                 <a:solidFill>
                   <a:srgbClr val="1E293B"/>
                 </a:solidFill>
@@ -6741,7 +6877,7 @@
               <a:spcAft>
                 <a:spcPts val="400"/>
               </a:spcAft>
-              <a:defRPr sz="1200">
+              <a:defRPr sz="1150">
                 <a:solidFill>
                   <a:srgbClr val="1E293B"/>
                 </a:solidFill>
@@ -6757,7 +6893,7 @@
               <a:spcAft>
                 <a:spcPts val="400"/>
               </a:spcAft>
-              <a:defRPr sz="1200">
+              <a:defRPr sz="1150">
                 <a:solidFill>
                   <a:srgbClr val="1E293B"/>
                 </a:solidFill>
@@ -6773,7 +6909,7 @@
               <a:spcAft>
                 <a:spcPts val="400"/>
               </a:spcAft>
-              <a:defRPr sz="1200">
+              <a:defRPr sz="1150">
                 <a:solidFill>
                   <a:srgbClr val="1E293B"/>
                 </a:solidFill>
@@ -6789,7 +6925,7 @@
               <a:spcAft>
                 <a:spcPts val="400"/>
               </a:spcAft>
-              <a:defRPr sz="1200">
+              <a:defRPr sz="1150">
                 <a:solidFill>
                   <a:srgbClr val="1E293B"/>
                 </a:solidFill>
@@ -6805,7 +6941,7 @@
               <a:spcAft>
                 <a:spcPts val="400"/>
               </a:spcAft>
-              <a:defRPr sz="1200">
+              <a:defRPr sz="1150">
                 <a:solidFill>
                   <a:srgbClr val="1E293B"/>
                 </a:solidFill>
@@ -6821,7 +6957,7 @@
               <a:spcAft>
                 <a:spcPts val="400"/>
               </a:spcAft>
-              <a:defRPr sz="1200">
+              <a:defRPr sz="1150">
                 <a:solidFill>
                   <a:srgbClr val="1E293B"/>
                 </a:solidFill>
@@ -6837,7 +6973,7 @@
               <a:spcAft>
                 <a:spcPts val="400"/>
               </a:spcAft>
-              <a:defRPr sz="1200">
+              <a:defRPr sz="1150">
                 <a:solidFill>
                   <a:srgbClr val="1E293B"/>
                 </a:solidFill>
@@ -6853,7 +6989,7 @@
               <a:spcAft>
                 <a:spcPts val="400"/>
               </a:spcAft>
-              <a:defRPr sz="1200">
+              <a:defRPr sz="1150">
                 <a:solidFill>
                   <a:srgbClr val="1E293B"/>
                 </a:solidFill>
@@ -6869,7 +7005,7 @@
               <a:spcAft>
                 <a:spcPts val="400"/>
               </a:spcAft>
-              <a:defRPr sz="1200">
+              <a:defRPr sz="1150">
                 <a:solidFill>
                   <a:srgbClr val="1E293B"/>
                 </a:solidFill>
@@ -6885,7 +7021,7 @@
               <a:spcAft>
                 <a:spcPts val="400"/>
               </a:spcAft>
-              <a:defRPr sz="1200">
+              <a:defRPr sz="1150">
                 <a:solidFill>
                   <a:srgbClr val="1E293B"/>
                 </a:solidFill>
@@ -6969,7 +7105,7 @@
               <a:spcAft>
                 <a:spcPts val="800"/>
               </a:spcAft>
-              <a:defRPr sz="1700" b="1">
+              <a:defRPr sz="1600" b="1">
                 <a:solidFill>
                   <a:srgbClr val="10B981"/>
                 </a:solidFill>
@@ -6989,7 +7125,7 @@
               <a:spcAft>
                 <a:spcPts val="400"/>
               </a:spcAft>
-              <a:defRPr sz="1200">
+              <a:defRPr sz="1150">
                 <a:solidFill>
                   <a:srgbClr val="1E293B"/>
                 </a:solidFill>
@@ -7005,7 +7141,7 @@
               <a:spcAft>
                 <a:spcPts val="400"/>
               </a:spcAft>
-              <a:defRPr sz="1200">
+              <a:defRPr sz="1150">
                 <a:solidFill>
                   <a:srgbClr val="1E293B"/>
                 </a:solidFill>
@@ -7021,7 +7157,7 @@
               <a:spcAft>
                 <a:spcPts val="400"/>
               </a:spcAft>
-              <a:defRPr sz="1200">
+              <a:defRPr sz="1150">
                 <a:solidFill>
                   <a:srgbClr val="1E293B"/>
                 </a:solidFill>
@@ -7037,7 +7173,7 @@
               <a:spcAft>
                 <a:spcPts val="400"/>
               </a:spcAft>
-              <a:defRPr sz="1200">
+              <a:defRPr sz="1150">
                 <a:solidFill>
                   <a:srgbClr val="1E293B"/>
                 </a:solidFill>
@@ -7053,7 +7189,7 @@
               <a:spcAft>
                 <a:spcPts val="400"/>
               </a:spcAft>
-              <a:defRPr sz="1200">
+              <a:defRPr sz="1150">
                 <a:solidFill>
                   <a:srgbClr val="1E293B"/>
                 </a:solidFill>
@@ -7069,7 +7205,7 @@
               <a:spcAft>
                 <a:spcPts val="400"/>
               </a:spcAft>
-              <a:defRPr sz="1200">
+              <a:defRPr sz="1150">
                 <a:solidFill>
                   <a:srgbClr val="1E293B"/>
                 </a:solidFill>
@@ -7085,7 +7221,7 @@
               <a:spcAft>
                 <a:spcPts val="400"/>
               </a:spcAft>
-              <a:defRPr sz="1200">
+              <a:defRPr sz="1150">
                 <a:solidFill>
                   <a:srgbClr val="1E293B"/>
                 </a:solidFill>
@@ -7101,7 +7237,7 @@
               <a:spcAft>
                 <a:spcPts val="400"/>
               </a:spcAft>
-              <a:defRPr sz="1200">
+              <a:defRPr sz="1150">
                 <a:solidFill>
                   <a:srgbClr val="1E293B"/>
                 </a:solidFill>
@@ -7117,7 +7253,7 @@
               <a:spcAft>
                 <a:spcPts val="400"/>
               </a:spcAft>
-              <a:defRPr sz="1200">
+              <a:defRPr sz="1150">
                 <a:solidFill>
                   <a:srgbClr val="1E293B"/>
                 </a:solidFill>
@@ -7201,7 +7337,7 @@
               <a:spcAft>
                 <a:spcPts val="800"/>
               </a:spcAft>
-              <a:defRPr sz="1700" b="1">
+              <a:defRPr sz="1600" b="1">
                 <a:solidFill>
                   <a:srgbClr val="F59E0B"/>
                 </a:solidFill>
@@ -7221,7 +7357,7 @@
               <a:spcAft>
                 <a:spcPts val="400"/>
               </a:spcAft>
-              <a:defRPr sz="1200">
+              <a:defRPr sz="1150">
                 <a:solidFill>
                   <a:srgbClr val="1E293B"/>
                 </a:solidFill>
@@ -7237,7 +7373,7 @@
               <a:spcAft>
                 <a:spcPts val="400"/>
               </a:spcAft>
-              <a:defRPr sz="1200">
+              <a:defRPr sz="1150">
                 <a:solidFill>
                   <a:srgbClr val="1E293B"/>
                 </a:solidFill>
@@ -7253,7 +7389,7 @@
               <a:spcAft>
                 <a:spcPts val="400"/>
               </a:spcAft>
-              <a:defRPr sz="1200">
+              <a:defRPr sz="1150">
                 <a:solidFill>
                   <a:srgbClr val="1E293B"/>
                 </a:solidFill>
@@ -7269,7 +7405,7 @@
               <a:spcAft>
                 <a:spcPts val="400"/>
               </a:spcAft>
-              <a:defRPr sz="1200">
+              <a:defRPr sz="1150">
                 <a:solidFill>
                   <a:srgbClr val="1E293B"/>
                 </a:solidFill>
@@ -7285,7 +7421,7 @@
               <a:spcAft>
                 <a:spcPts val="400"/>
               </a:spcAft>
-              <a:defRPr sz="1200">
+              <a:defRPr sz="1150">
                 <a:solidFill>
                   <a:srgbClr val="1E293B"/>
                 </a:solidFill>
@@ -7301,7 +7437,7 @@
               <a:spcAft>
                 <a:spcPts val="400"/>
               </a:spcAft>
-              <a:defRPr sz="1200">
+              <a:defRPr sz="1150">
                 <a:solidFill>
                   <a:srgbClr val="1E293B"/>
                 </a:solidFill>
@@ -7317,7 +7453,7 @@
               <a:spcAft>
                 <a:spcPts val="400"/>
               </a:spcAft>
-              <a:defRPr sz="1200">
+              <a:defRPr sz="1150">
                 <a:solidFill>
                   <a:srgbClr val="1E293B"/>
                 </a:solidFill>
@@ -8433,7 +8569,7 @@
               <a:spcAft>
                 <a:spcPts val="800"/>
               </a:spcAft>
-              <a:defRPr sz="1700" b="1">
+              <a:defRPr sz="1600" b="1">
                 <a:solidFill>
                   <a:srgbClr val="0066FF"/>
                 </a:solidFill>
@@ -8449,7 +8585,7 @@
               <a:spcAft>
                 <a:spcPts val="400"/>
               </a:spcAft>
-              <a:defRPr sz="1200">
+              <a:defRPr sz="1150">
                 <a:solidFill>
                   <a:srgbClr val="1E293B"/>
                 </a:solidFill>
@@ -8465,7 +8601,7 @@
               <a:spcAft>
                 <a:spcPts val="400"/>
               </a:spcAft>
-              <a:defRPr sz="1200">
+              <a:defRPr sz="1150">
                 <a:solidFill>
                   <a:srgbClr val="1E293B"/>
                 </a:solidFill>
@@ -8549,7 +8685,7 @@
               <a:spcAft>
                 <a:spcPts val="800"/>
               </a:spcAft>
-              <a:defRPr sz="1700" b="1">
+              <a:defRPr sz="1600" b="1">
                 <a:solidFill>
                   <a:srgbClr val="F59E0B"/>
                 </a:solidFill>
@@ -8565,7 +8701,7 @@
               <a:spcAft>
                 <a:spcPts val="400"/>
               </a:spcAft>
-              <a:defRPr sz="1200">
+              <a:defRPr sz="1150">
                 <a:solidFill>
                   <a:srgbClr val="1E293B"/>
                 </a:solidFill>
@@ -8581,7 +8717,7 @@
               <a:spcAft>
                 <a:spcPts val="400"/>
               </a:spcAft>
-              <a:defRPr sz="1200">
+              <a:defRPr sz="1150">
                 <a:solidFill>
                   <a:srgbClr val="1E293B"/>
                 </a:solidFill>
@@ -8597,7 +8733,7 @@
               <a:spcAft>
                 <a:spcPts val="400"/>
               </a:spcAft>
-              <a:defRPr sz="1200">
+              <a:defRPr sz="1150">
                 <a:solidFill>
                   <a:srgbClr val="1E293B"/>
                 </a:solidFill>
@@ -8681,7 +8817,7 @@
               <a:spcAft>
                 <a:spcPts val="800"/>
               </a:spcAft>
-              <a:defRPr sz="1700" b="1">
+              <a:defRPr sz="1600" b="1">
                 <a:solidFill>
                   <a:srgbClr val="10B981"/>
                 </a:solidFill>
@@ -8697,7 +8833,7 @@
               <a:spcAft>
                 <a:spcPts val="400"/>
               </a:spcAft>
-              <a:defRPr sz="1200">
+              <a:defRPr sz="1150">
                 <a:solidFill>
                   <a:srgbClr val="1E293B"/>
                 </a:solidFill>
@@ -8713,7 +8849,7 @@
               <a:spcAft>
                 <a:spcPts val="400"/>
               </a:spcAft>
-              <a:defRPr sz="1200">
+              <a:defRPr sz="1150">
                 <a:solidFill>
                   <a:srgbClr val="1E293B"/>
                 </a:solidFill>
@@ -8797,7 +8933,7 @@
               <a:spcAft>
                 <a:spcPts val="800"/>
               </a:spcAft>
-              <a:defRPr sz="1700" b="1">
+              <a:defRPr sz="1600" b="1">
                 <a:solidFill>
                   <a:srgbClr val="0066FF"/>
                 </a:solidFill>
@@ -8813,7 +8949,7 @@
               <a:spcAft>
                 <a:spcPts val="400"/>
               </a:spcAft>
-              <a:defRPr sz="1200">
+              <a:defRPr sz="1150">
                 <a:solidFill>
                   <a:srgbClr val="1E293B"/>
                 </a:solidFill>
@@ -8829,7 +8965,7 @@
               <a:spcAft>
                 <a:spcPts val="400"/>
               </a:spcAft>
-              <a:defRPr sz="1200">
+              <a:defRPr sz="1150">
                 <a:solidFill>
                   <a:srgbClr val="1E293B"/>
                 </a:solidFill>
@@ -9025,7 +9161,7 @@
               <a:spcAft>
                 <a:spcPts val="800"/>
               </a:spcAft>
-              <a:defRPr sz="1700" b="1">
+              <a:defRPr sz="1600" b="1">
                 <a:solidFill>
                   <a:srgbClr val="0066FF"/>
                 </a:solidFill>
@@ -9041,7 +9177,7 @@
               <a:spcAft>
                 <a:spcPts val="400"/>
               </a:spcAft>
-              <a:defRPr sz="1200">
+              <a:defRPr sz="1150">
                 <a:solidFill>
                   <a:srgbClr val="1E293B"/>
                 </a:solidFill>
@@ -9057,7 +9193,7 @@
               <a:spcAft>
                 <a:spcPts val="400"/>
               </a:spcAft>
-              <a:defRPr sz="1200">
+              <a:defRPr sz="1150">
                 <a:solidFill>
                   <a:srgbClr val="1E293B"/>
                 </a:solidFill>
@@ -9073,7 +9209,7 @@
               <a:spcAft>
                 <a:spcPts val="400"/>
               </a:spcAft>
-              <a:defRPr sz="1200">
+              <a:defRPr sz="1150">
                 <a:solidFill>
                   <a:srgbClr val="1E293B"/>
                 </a:solidFill>
@@ -9157,7 +9293,7 @@
               <a:spcAft>
                 <a:spcPts val="800"/>
               </a:spcAft>
-              <a:defRPr sz="1700" b="1">
+              <a:defRPr sz="1600" b="1">
                 <a:solidFill>
                   <a:srgbClr val="F59E0B"/>
                 </a:solidFill>
@@ -9173,7 +9309,7 @@
               <a:spcAft>
                 <a:spcPts val="400"/>
               </a:spcAft>
-              <a:defRPr sz="1200">
+              <a:defRPr sz="1150">
                 <a:solidFill>
                   <a:srgbClr val="1E293B"/>
                 </a:solidFill>
@@ -9189,7 +9325,7 @@
               <a:spcAft>
                 <a:spcPts val="400"/>
               </a:spcAft>
-              <a:defRPr sz="1200">
+              <a:defRPr sz="1150">
                 <a:solidFill>
                   <a:srgbClr val="1E293B"/>
                 </a:solidFill>
@@ -9205,7 +9341,7 @@
               <a:spcAft>
                 <a:spcPts val="400"/>
               </a:spcAft>
-              <a:defRPr sz="1200">
+              <a:defRPr sz="1150">
                 <a:solidFill>
                   <a:srgbClr val="1E293B"/>
                 </a:solidFill>
@@ -9289,7 +9425,7 @@
               <a:spcAft>
                 <a:spcPts val="800"/>
               </a:spcAft>
-              <a:defRPr sz="1700" b="1">
+              <a:defRPr sz="1600" b="1">
                 <a:solidFill>
                   <a:srgbClr val="10B981"/>
                 </a:solidFill>
@@ -9305,7 +9441,7 @@
               <a:spcAft>
                 <a:spcPts val="400"/>
               </a:spcAft>
-              <a:defRPr sz="1200">
+              <a:defRPr sz="1150">
                 <a:solidFill>
                   <a:srgbClr val="1E293B"/>
                 </a:solidFill>
@@ -9321,7 +9457,7 @@
               <a:spcAft>
                 <a:spcPts val="400"/>
               </a:spcAft>
-              <a:defRPr sz="1200">
+              <a:defRPr sz="1150">
                 <a:solidFill>
                   <a:srgbClr val="1E293B"/>
                 </a:solidFill>
@@ -9337,7 +9473,7 @@
               <a:spcAft>
                 <a:spcPts val="400"/>
               </a:spcAft>
-              <a:defRPr sz="1200">
+              <a:defRPr sz="1150">
                 <a:solidFill>
                   <a:srgbClr val="1E293B"/>
                 </a:solidFill>
@@ -9421,7 +9557,7 @@
               <a:spcAft>
                 <a:spcPts val="800"/>
               </a:spcAft>
-              <a:defRPr sz="1700" b="1">
+              <a:defRPr sz="1600" b="1">
                 <a:solidFill>
                   <a:srgbClr val="0066FF"/>
                 </a:solidFill>
@@ -9437,7 +9573,7 @@
               <a:spcAft>
                 <a:spcPts val="400"/>
               </a:spcAft>
-              <a:defRPr sz="1200">
+              <a:defRPr sz="1150">
                 <a:solidFill>
                   <a:srgbClr val="1E293B"/>
                 </a:solidFill>
@@ -9453,7 +9589,7 @@
               <a:spcAft>
                 <a:spcPts val="400"/>
               </a:spcAft>
-              <a:defRPr sz="1200">
+              <a:defRPr sz="1150">
                 <a:solidFill>
                   <a:srgbClr val="1E293B"/>
                 </a:solidFill>
@@ -9469,7 +9605,7 @@
               <a:spcAft>
                 <a:spcPts val="400"/>
               </a:spcAft>
-              <a:defRPr sz="1200">
+              <a:defRPr sz="1150">
                 <a:solidFill>
                   <a:srgbClr val="1E293B"/>
                 </a:solidFill>
@@ -9665,7 +9801,7 @@
               <a:spcAft>
                 <a:spcPts val="800"/>
               </a:spcAft>
-              <a:defRPr sz="1700" b="1">
+              <a:defRPr sz="1600" b="1">
                 <a:solidFill>
                   <a:srgbClr val="0066FF"/>
                 </a:solidFill>
@@ -9681,7 +9817,7 @@
               <a:spcAft>
                 <a:spcPts val="400"/>
               </a:spcAft>
-              <a:defRPr sz="1200">
+              <a:defRPr sz="1150">
                 <a:solidFill>
                   <a:srgbClr val="1E293B"/>
                 </a:solidFill>
@@ -9697,7 +9833,7 @@
               <a:spcAft>
                 <a:spcPts val="400"/>
               </a:spcAft>
-              <a:defRPr sz="1200">
+              <a:defRPr sz="1150">
                 <a:solidFill>
                   <a:srgbClr val="1E293B"/>
                 </a:solidFill>
@@ -9713,7 +9849,7 @@
               <a:spcAft>
                 <a:spcPts val="400"/>
               </a:spcAft>
-              <a:defRPr sz="1200">
+              <a:defRPr sz="1150">
                 <a:solidFill>
                   <a:srgbClr val="1E293B"/>
                 </a:solidFill>
@@ -9729,7 +9865,7 @@
               <a:spcAft>
                 <a:spcPts val="400"/>
               </a:spcAft>
-              <a:defRPr sz="1200">
+              <a:defRPr sz="1150">
                 <a:solidFill>
                   <a:srgbClr val="1E293B"/>
                 </a:solidFill>
@@ -9813,7 +9949,7 @@
               <a:spcAft>
                 <a:spcPts val="800"/>
               </a:spcAft>
-              <a:defRPr sz="1700" b="1">
+              <a:defRPr sz="1600" b="1">
                 <a:solidFill>
                   <a:srgbClr val="F59E0B"/>
                 </a:solidFill>
@@ -9829,7 +9965,7 @@
               <a:spcAft>
                 <a:spcPts val="400"/>
               </a:spcAft>
-              <a:defRPr sz="1200">
+              <a:defRPr sz="1150">
                 <a:solidFill>
                   <a:srgbClr val="1E293B"/>
                 </a:solidFill>
@@ -9845,7 +9981,7 @@
               <a:spcAft>
                 <a:spcPts val="400"/>
               </a:spcAft>
-              <a:defRPr sz="1200">
+              <a:defRPr sz="1150">
                 <a:solidFill>
                   <a:srgbClr val="1E293B"/>
                 </a:solidFill>
@@ -9861,7 +9997,7 @@
               <a:spcAft>
                 <a:spcPts val="400"/>
               </a:spcAft>
-              <a:defRPr sz="1200">
+              <a:defRPr sz="1150">
                 <a:solidFill>
                   <a:srgbClr val="1E293B"/>
                 </a:solidFill>
@@ -9877,7 +10013,7 @@
               <a:spcAft>
                 <a:spcPts val="400"/>
               </a:spcAft>
-              <a:defRPr sz="1200">
+              <a:defRPr sz="1150">
                 <a:solidFill>
                   <a:srgbClr val="1E293B"/>
                 </a:solidFill>

</xml_diff>